<commit_message>
Fork da turma 1705 para a 1751 (09/09→28/09/2026)
Atualiza README, cronograma, checklist prévio, brief do projeto final e o
deck da Aula 1. Remove os decks das Aulas 2–9 (na 1705 as aulas seguiram
com material do aluno + código compartilhado) e arquivos .DS_Store.

Co-Authored-By: Claude Fable 5.1 <noreply@anthropic.com>
Claude-Session: https://claude.ai/code/session_01Jg9VXhraYS5zkWchM7qv2y
</commit_message>
<xml_diff>
--- a/plano-de-aulas/aula-01-slides.pptx
+++ b/plano-de-aulas/aula-01-slides.pptx
@@ -4542,7 +4542,7 @@
           </a:p>
           <a:p>
             <a:r>
-              <a:t>Turma sênior: debate de alto nível + ponte com o legado</a:t>
+              <a:t>Debate de alto nível + ponte com o legado</a:t>
             </a:r>
           </a:p>
         </p:txBody>
@@ -4727,47 +4727,47 @@
           <a:lstStyle/>
           <a:p>
             <a:r>
-              <a:t>22/06 Abertura + DDD e fronteiras</a:t>
-            </a:r>
-          </a:p>
-          <a:p>
-            <a:r>
-              <a:t>24/06 Consistência distribuída e SAGA</a:t>
-            </a:r>
-          </a:p>
-          <a:p>
-            <a:r>
-              <a:t>26/06 Cache com Redis</a:t>
-            </a:r>
-          </a:p>
-          <a:p>
-            <a:r>
-              <a:t>29/06 Comunicação assíncrona (producer/consumer)</a:t>
-            </a:r>
-          </a:p>
-          <a:p>
-            <a:r>
-              <a:t>01/07 Filas com RabbitMQ + DLQ</a:t>
-            </a:r>
-          </a:p>
-          <a:p>
-            <a:r>
-              <a:t>03/07 Tópicos/eventos com Kafka</a:t>
-            </a:r>
-          </a:p>
-          <a:p>
-            <a:r>
-              <a:t>06/07 Resiliência e retry</a:t>
-            </a:r>
-          </a:p>
-          <a:p>
-            <a:r>
-              <a:t>08/07 Contract testing (PACT)</a:t>
-            </a:r>
-          </a:p>
-          <a:p>
-            <a:r>
-              <a:t>10/07 Bancas dos projetos + devolutiva</a:t>
+              <a:t>09/09 Abertura + DDD e fronteiras</a:t>
+            </a:r>
+          </a:p>
+          <a:p>
+            <a:r>
+              <a:t>11/09 DDD na prática + SAGA</a:t>
+            </a:r>
+          </a:p>
+          <a:p>
+            <a:r>
+              <a:t>14/09 Comunicação entre microsserviços</a:t>
+            </a:r>
+          </a:p>
+          <a:p>
+            <a:r>
+              <a:t>16/09 Cache com Redis</a:t>
+            </a:r>
+          </a:p>
+          <a:p>
+            <a:r>
+              <a:t>18/09 Comunicação assíncrona (producer/consumer)</a:t>
+            </a:r>
+          </a:p>
+          <a:p>
+            <a:r>
+              <a:t>21/09 Filas com RabbitMQ + DLQ</a:t>
+            </a:r>
+          </a:p>
+          <a:p>
+            <a:r>
+              <a:t>23/09 Tópicos/eventos com Kafka</a:t>
+            </a:r>
+          </a:p>
+          <a:p>
+            <a:r>
+              <a:t>25/09 Resiliência + Contract testing (PACT)</a:t>
+            </a:r>
+          </a:p>
+          <a:p>
+            <a:r>
+              <a:t>28/09 Bancas dos projetos + devolutiva</a:t>
             </a:r>
           </a:p>
         </p:txBody>
@@ -4952,7 +4952,7 @@
           </a:p>
           <a:p>
             <a:r>
-              <a:t>Desenvolvido na 2ª metade das aulas; defesa na banca (10/07)</a:t>
+              <a:t>Desenvolvido na 2ª metade das aulas; defesa na banca (28/09)</a:t>
             </a:r>
           </a:p>
           <a:p>

</xml_diff>